<commit_message>
fix: convert all amounts from USD to INR in client pitch deck
Market size: ₹70,000 Cr+, pricing tiers: ₹82K–₹21L/mo,
ARR projections: ₹12.5 Cr → ₹1,000 Cr (5-year),
AI market: ₹17,500 Cr. All figures now in Indian Rupees.

Co-Authored-By: Claude Opus 4.6 <noreply@anthropic.com>
</commit_message>
<xml_diff>
--- a/docs/presentations/HMS_Enterprise_Client_Pitch_Deck.pptx
+++ b/docs/presentations/HMS_Enterprise_Client_Pitch_Deck.pptx
@@ -6435,7 +6435,7 @@
               </a:defRPr>
             </a:pPr>
             <a:r>
-              <a:t>$2.1B</a:t>
+              <a:t>₹17,500Cr</a:t>
             </a:r>
           </a:p>
         </p:txBody>
@@ -8213,7 +8213,7 @@
               </a:defRPr>
             </a:pPr>
             <a:r>
-              <a:t>$999–$2,500/mo</a:t>
+              <a:t>₹82K–₹2.1L/mo</a:t>
             </a:r>
           </a:p>
         </p:txBody>
@@ -8642,7 +8642,7 @@
               </a:defRPr>
             </a:pPr>
             <a:r>
-              <a:t>$5K–$15K/mo</a:t>
+              <a:t>₹4.2L–₹12.5L/mo</a:t>
             </a:r>
           </a:p>
         </p:txBody>
@@ -9071,7 +9071,7 @@
               </a:defRPr>
             </a:pPr>
             <a:r>
-              <a:t>$15K–$25K/mo</a:t>
+              <a:t>₹12.5L–₹21L/mo</a:t>
             </a:r>
           </a:p>
         </p:txBody>
@@ -9827,7 +9827,7 @@
               </a:defRPr>
             </a:pPr>
             <a:r>
-              <a:t>$1.5M</a:t>
+              <a:t>₹12.5 Cr</a:t>
             </a:r>
           </a:p>
         </p:txBody>
@@ -10050,7 +10050,7 @@
               </a:defRPr>
             </a:pPr>
             <a:r>
-              <a:t>$8M</a:t>
+              <a:t>₹67 Cr</a:t>
             </a:r>
           </a:p>
         </p:txBody>
@@ -10273,7 +10273,7 @@
               </a:defRPr>
             </a:pPr>
             <a:r>
-              <a:t>$28M</a:t>
+              <a:t>₹234 Cr</a:t>
             </a:r>
           </a:p>
         </p:txBody>
@@ -10496,7 +10496,7 @@
               </a:defRPr>
             </a:pPr>
             <a:r>
-              <a:t>$120M</a:t>
+              <a:t>₹1,000 Cr</a:t>
             </a:r>
           </a:p>
         </p:txBody>
@@ -15342,7 +15342,7 @@
               </a:defRPr>
             </a:pPr>
             <a:r>
-              <a:t>$8.5B market with massive digital gap</a:t>
+              <a:t>₹70,000 Cr+ market with massive digital gap</a:t>
             </a:r>
           </a:p>
         </p:txBody>
@@ -18827,7 +18827,7 @@
               </a:defRPr>
             </a:pPr>
             <a:r>
-              <a:t>$8.5B</a:t>
+              <a:t>₹70,000Cr+</a:t>
             </a:r>
           </a:p>
         </p:txBody>

</xml_diff>